<commit_message>
Add a Sources and go deeper block to every room and download.
Each room, chapter, section export, cheat sheet, template, flashcard, and diagram page now ends with links opened in October 2026. Every room keeps sources.json. A page that 404s or lands on a different article is marked confirm.

Co-authored-by: CYPHER0X9 <cipher0x9@users.noreply.github.com>
</commit_message>
<xml_diff>
--- a/downloads/connect-study-deck.pptx
+++ b/downloads/connect-study-deck.pptx
@@ -3237,7 +3237,7 @@
           <a:lstStyle/>
           <a:p>
             <a:r>
-              <a:t>Independent study lab</a:t>
+              <a:t>Sources and go deeper</a:t>
             </a:r>
           </a:p>
         </p:txBody>
@@ -3258,7 +3258,55 @@
           <a:lstStyle/>
           <a:p>
             <a:r>
-              <a:t>This is an independent, free, learning-only student project. It respects every company and vendor. Trademarks belong to their owners. It is not affiliated with or endorsed by Amazon Web Services, Cisco, Genesys, or any other company. If you have a concern, the page will be removed or corrected promptly through the contact form. Nothing here is sold. There are no ads. The author is happy to volunteer for any organization. Contact: https://cyphermonkeylabs.com/#contact</a:t>
+              <a:t>This is an independent, free, learning-only student project. It respects every company and vendor. Trademarks belong to their owners. It is not affiliated with or endorsed by Amazon Web Services, Cisco, Genesys, or any other company. If you have a concern, the page will be removed or corrected promptly through the contact form. Nothing here is sold. There are no ads. The author is happy to volunteer for any organization.</a:t>
+            </a:r>
+          </a:p>
+          <a:p>
+            <a:pPr>
+              <a:defRPr sz="1400"/>
+            </a:pPr>
+            <a:r>
+              <a:t>What is Connect Customer? - Amazon Connect Customer (AWS docs) https://docs.aws.amazon.com/connect/latest/adminguide/what-is-amazon-connect.html last checked 2026-10</a:t>
+            </a:r>
+          </a:p>
+          <a:p>
+            <a:pPr>
+              <a:defRPr sz="1400"/>
+            </a:pPr>
+            <a:r>
+              <a:t>RFC 3261: SIP: Session Initiation Protocol | RFC Editor (RFC) https://www.rfc-editor.org/info/rfc3261/ last checked 2026-10</a:t>
+            </a:r>
+          </a:p>
+          <a:p>
+            <a:pPr>
+              <a:defRPr sz="1400"/>
+            </a:pPr>
+            <a:r>
+              <a:t>Troubleshoot contact flow errors in Amazon Connect | AWS re:Post (community) https://repost.aws/knowledge-center/connect-contact-flow-errors last checked 2026-10</a:t>
+            </a:r>
+          </a:p>
+          <a:p>
+            <a:pPr>
+              <a:defRPr sz="1400"/>
+            </a:pPr>
+            <a:r>
+              <a:t>AWS History and Timeline regarding Amazon Connect - Overview, Functions, Features, Summary of Updates, and Introduction to Amazon Connect Customer | hidekazu-ko (community) https://hidekazu-konishi.com/entry/aws_history_and_timeline_amazon_connect.html last checked 2026-10</a:t>
+            </a:r>
+          </a:p>
+          <a:p>
+            <a:pPr>
+              <a:defRPr sz="1400"/>
+            </a:pPr>
+            <a:r>
+              <a:t>Call centre - Wikipedia (Wikipedia) https://en.wikipedia.org/wiki/Call_centre last checked 2026-10</a:t>
+            </a:r>
+          </a:p>
+          <a:p>
+            <a:pPr>
+              <a:defRPr sz="1400"/>
+            </a:pPr>
+            <a:r>
+              <a:t>Contact: https://cyphermonkeylabs.com/#contact</a:t>
             </a:r>
           </a:p>
         </p:txBody>

</xml_diff>

<commit_message>
Add five cited chapters from fundamentals to advanced.
Routing, forecasting, Contact Lens, CRM and CPaaS, and the ecosystem now have menu rows, chapter pages, and rooms whose numbers come from pages opened in October 2026. Home counts stay tied to the files the build writes.

Co-authored-by: CYPHER0X9 <cipher0x9@users.noreply.github.com>
</commit_message>
<xml_diff>
--- a/downloads/connect-study-deck.pptx
+++ b/downloads/connect-study-deck.pptx
@@ -16,6 +16,10 @@
     <p:sldId id="264" r:id="rId15"/>
     <p:sldId id="265" r:id="rId16"/>
     <p:sldId id="266" r:id="rId17"/>
+    <p:sldId id="267" r:id="rId18"/>
+    <p:sldId id="268" r:id="rId19"/>
+    <p:sldId id="269" r:id="rId20"/>
+    <p:sldId id="270" r:id="rId21"/>
   </p:sldIdLst>
   <p:sldSz cx="9144000" cy="6858000" type="screen4x3"/>
   <p:notesSz cx="6858000" cy="9144000"/>
@@ -3135,7 +3139,7 @@
           <a:lstStyle/>
           <a:p>
             <a:r>
-              <a:t>Independent learning lab. This is an independent, free, learning-only student project. It respects every company and vendor. Trademarks belong to their owners. It is not affiliated with or endorsed by Amazon Web Services, Cisco, Genesys, or any other company. If you have a concern, the page will be removed or corrected promptly through the contact form. Nothing here is sold. There are no ads. The author is happy to volunteer for any organization.</a:t>
+              <a:t>Independent learning lab. This is an independent, free, learning-only student project. It respects every company and vendor. Trademarks belong to their owners. It is not affiliated with or endorsed by Amazon Web Services, Cisco, Genesys, Salesforce, Twilio, or any other company. If you have a concern, the page will be removed or corrected promptly through the contact form. Nothing here is sold. There are no ads. The author is happy to volunteer for any organization.</a:t>
             </a:r>
           </a:p>
         </p:txBody>
@@ -3174,7 +3178,7 @@
           <a:lstStyle/>
           <a:p>
             <a:r>
-              <a:t>Confirm</a:t>
+              <a:t>Skills routing</a:t>
             </a:r>
           </a:p>
         </p:txBody>
@@ -3198,7 +3202,7 @@
               <a:defRPr sz="2000"/>
             </a:pPr>
             <a:r>
-              <a:t>Prices, quotas, and exam names change. Confirm before relying. Nothing in this deck is an invoice.</a:t>
+              <a:t>Proficiency steps run after Transfer to queue. They do not run in an agent queue.</a:t>
             </a:r>
           </a:p>
         </p:txBody>
@@ -3237,6 +3241,258 @@
           <a:lstStyle/>
           <a:p>
             <a:r>
+              <a:t>Forecasting</a:t>
+            </a:r>
+          </a:p>
+        </p:txBody>
+      </p:sp>
+      <p:sp>
+        <p:nvSpPr>
+          <p:cNvPr id="3" name="Content Placeholder 2"/>
+          <p:cNvSpPr>
+            <a:spLocks noGrp="1"/>
+          </p:cNvSpPr>
+          <p:nvPr>
+            <p:ph idx="1"/>
+          </p:nvPr>
+        </p:nvSpPr>
+        <p:spPr/>
+        <p:txBody>
+          <a:bodyPr/>
+          <a:lstStyle/>
+          <a:p>
+            <a:pPr>
+              <a:defRPr sz="2000"/>
+            </a:pPr>
+            <a:r>
+              <a:t>Set 15 or 30 minutes once. Publish a forecast before a schedule. Adherence follows a published schedule.</a:t>
+            </a:r>
+          </a:p>
+        </p:txBody>
+      </p:sp>
+    </p:spTree>
+  </p:cSld>
+  <p:clrMapOvr>
+    <a:masterClrMapping/>
+  </p:clrMapOvr>
+</p:sld>
+</file>
+
+<file path=ppt/slides/slide12.xml><?xml version="1.0" encoding="utf-8"?>
+<p:sld xmlns:a="http://schemas.openxmlformats.org/drawingml/2006/main" xmlns:p="http://schemas.openxmlformats.org/presentationml/2006/main" xmlns:r="http://schemas.openxmlformats.org/officeDocument/2006/relationships">
+  <p:cSld>
+    <p:spTree>
+      <p:nvGrpSpPr>
+        <p:cNvPr id="1" name=""/>
+        <p:cNvGrpSpPr/>
+        <p:nvPr/>
+      </p:nvGrpSpPr>
+      <p:grpSpPr/>
+      <p:sp>
+        <p:nvSpPr>
+          <p:cNvPr id="2" name="Title 1"/>
+          <p:cNvSpPr>
+            <a:spLocks noGrp="1"/>
+          </p:cNvSpPr>
+          <p:nvPr>
+            <p:ph type="title"/>
+          </p:nvPr>
+        </p:nvSpPr>
+        <p:spPr/>
+        <p:txBody>
+          <a:bodyPr/>
+          <a:lstStyle/>
+          <a:p>
+            <a:r>
+              <a:t>Quality</a:t>
+            </a:r>
+          </a:p>
+        </p:txBody>
+      </p:sp>
+      <p:sp>
+        <p:nvSpPr>
+          <p:cNvPr id="3" name="Content Placeholder 2"/>
+          <p:cNvSpPr>
+            <a:spLocks noGrp="1"/>
+          </p:cNvSpPr>
+          <p:nvPr>
+            <p:ph idx="1"/>
+          </p:nvPr>
+        </p:nvSpPr>
+        <p:spPr/>
+        <p:txBody>
+          <a:bodyPr/>
+          <a:lstStyle/>
+          <a:p>
+            <a:pPr>
+              <a:defRPr sz="2000"/>
+            </a:pPr>
+            <a:r>
+              <a:t>Conversational analytics needs the flow block. An evaluation form is activated after its questions exist.</a:t>
+            </a:r>
+          </a:p>
+        </p:txBody>
+      </p:sp>
+    </p:spTree>
+  </p:cSld>
+  <p:clrMapOvr>
+    <a:masterClrMapping/>
+  </p:clrMapOvr>
+</p:sld>
+</file>
+
+<file path=ppt/slides/slide13.xml><?xml version="1.0" encoding="utf-8"?>
+<p:sld xmlns:a="http://schemas.openxmlformats.org/drawingml/2006/main" xmlns:p="http://schemas.openxmlformats.org/presentationml/2006/main" xmlns:r="http://schemas.openxmlformats.org/officeDocument/2006/relationships">
+  <p:cSld>
+    <p:spTree>
+      <p:nvGrpSpPr>
+        <p:cNvPr id="1" name=""/>
+        <p:cNvGrpSpPr/>
+        <p:nvPr/>
+      </p:nvGrpSpPr>
+      <p:grpSpPr/>
+      <p:sp>
+        <p:nvSpPr>
+          <p:cNvPr id="2" name="Title 1"/>
+          <p:cNvSpPr>
+            <a:spLocks noGrp="1"/>
+          </p:cNvSpPr>
+          <p:nvPr>
+            <p:ph type="title"/>
+          </p:nvPr>
+        </p:nvSpPr>
+        <p:spPr/>
+        <p:txBody>
+          <a:bodyPr/>
+          <a:lstStyle/>
+          <a:p>
+            <a:r>
+              <a:t>CRM and CPaaS</a:t>
+            </a:r>
+          </a:p>
+        </p:txBody>
+      </p:sp>
+      <p:sp>
+        <p:nvSpPr>
+          <p:cNvPr id="3" name="Content Placeholder 2"/>
+          <p:cNvSpPr>
+            <a:spLocks noGrp="1"/>
+          </p:cNvSpPr>
+          <p:nvPr>
+            <p:ph idx="1"/>
+          </p:nvPr>
+        </p:nvSpPr>
+        <p:spPr/>
+        <p:txBody>
+          <a:bodyPr/>
+          <a:lstStyle/>
+          <a:p>
+            <a:pPr>
+              <a:defRPr sz="2000"/>
+            </a:pPr>
+            <a:r>
+              <a:t>Salesforce on Connect is a CCP embed, sandbox first. Twilio Flex documents its own embed. No Connect connector page was opened.</a:t>
+            </a:r>
+          </a:p>
+        </p:txBody>
+      </p:sp>
+    </p:spTree>
+  </p:cSld>
+  <p:clrMapOvr>
+    <a:masterClrMapping/>
+  </p:clrMapOvr>
+</p:sld>
+</file>
+
+<file path=ppt/slides/slide14.xml><?xml version="1.0" encoding="utf-8"?>
+<p:sld xmlns:a="http://schemas.openxmlformats.org/drawingml/2006/main" xmlns:p="http://schemas.openxmlformats.org/presentationml/2006/main" xmlns:r="http://schemas.openxmlformats.org/officeDocument/2006/relationships">
+  <p:cSld>
+    <p:spTree>
+      <p:nvGrpSpPr>
+        <p:cNvPr id="1" name=""/>
+        <p:cNvGrpSpPr/>
+        <p:nvPr/>
+      </p:nvGrpSpPr>
+      <p:grpSpPr/>
+      <p:sp>
+        <p:nvSpPr>
+          <p:cNvPr id="2" name="Title 1"/>
+          <p:cNvSpPr>
+            <a:spLocks noGrp="1"/>
+          </p:cNvSpPr>
+          <p:nvPr>
+            <p:ph type="title"/>
+          </p:nvPr>
+        </p:nvSpPr>
+        <p:spPr/>
+        <p:txBody>
+          <a:bodyPr/>
+          <a:lstStyle/>
+          <a:p>
+            <a:r>
+              <a:t>Confirm</a:t>
+            </a:r>
+          </a:p>
+        </p:txBody>
+      </p:sp>
+      <p:sp>
+        <p:nvSpPr>
+          <p:cNvPr id="3" name="Content Placeholder 2"/>
+          <p:cNvSpPr>
+            <a:spLocks noGrp="1"/>
+          </p:cNvSpPr>
+          <p:nvPr>
+            <p:ph idx="1"/>
+          </p:nvPr>
+        </p:nvSpPr>
+        <p:spPr/>
+        <p:txBody>
+          <a:bodyPr/>
+          <a:lstStyle/>
+          <a:p>
+            <a:pPr>
+              <a:defRPr sz="2000"/>
+            </a:pPr>
+            <a:r>
+              <a:t>Prices, quotas, and exam names change. Confirm before relying. Nothing in this deck is an invoice.</a:t>
+            </a:r>
+          </a:p>
+        </p:txBody>
+      </p:sp>
+    </p:spTree>
+  </p:cSld>
+  <p:clrMapOvr>
+    <a:masterClrMapping/>
+  </p:clrMapOvr>
+</p:sld>
+</file>
+
+<file path=ppt/slides/slide15.xml><?xml version="1.0" encoding="utf-8"?>
+<p:sld xmlns:a="http://schemas.openxmlformats.org/drawingml/2006/main" xmlns:p="http://schemas.openxmlformats.org/presentationml/2006/main" xmlns:r="http://schemas.openxmlformats.org/officeDocument/2006/relationships">
+  <p:cSld>
+    <p:spTree>
+      <p:nvGrpSpPr>
+        <p:cNvPr id="1" name=""/>
+        <p:cNvGrpSpPr/>
+        <p:nvPr/>
+      </p:nvGrpSpPr>
+      <p:grpSpPr/>
+      <p:sp>
+        <p:nvSpPr>
+          <p:cNvPr id="2" name="Title 1"/>
+          <p:cNvSpPr>
+            <a:spLocks noGrp="1"/>
+          </p:cNvSpPr>
+          <p:nvPr>
+            <p:ph type="title"/>
+          </p:nvPr>
+        </p:nvSpPr>
+        <p:spPr/>
+        <p:txBody>
+          <a:bodyPr/>
+          <a:lstStyle/>
+          <a:p>
+            <a:r>
               <a:t>Sources and go deeper</a:t>
             </a:r>
           </a:p>
@@ -3258,7 +3514,7 @@
           <a:lstStyle/>
           <a:p>
             <a:r>
-              <a:t>This is an independent, free, learning-only student project. It respects every company and vendor. Trademarks belong to their owners. It is not affiliated with or endorsed by Amazon Web Services, Cisco, Genesys, or any other company. If you have a concern, the page will be removed or corrected promptly through the contact form. Nothing here is sold. There are no ads. The author is happy to volunteer for any organization.</a:t>
+              <a:t>This is an independent, free, learning-only student project. It respects every company and vendor. Trademarks belong to their owners. It is not affiliated with or endorsed by Amazon Web Services, Cisco, Genesys, Salesforce, Twilio, or any other company. If you have a concern, the page will be removed or corrected promptly through the contact form. Nothing here is sold. There are no ads. The author is happy to volunteer for any organization.</a:t>
             </a:r>
           </a:p>
           <a:p>

</xml_diff>

<commit_message>
Add five cited chapters from fundamentals to advanced. (#9)
Routing, forecasting, Contact Lens, CRM and CPaaS, and the ecosystem now have menu rows, chapter pages, and rooms whose numbers come from pages opened in October 2026. Home counts stay tied to the files the build writes.

Co-authored-by: Cursor Agent <cursoragent@cursor.com>
Co-authored-by: CYPHER0X9 <cipher0x9@users.noreply.github.com>
</commit_message>
<xml_diff>
--- a/downloads/connect-study-deck.pptx
+++ b/downloads/connect-study-deck.pptx
@@ -16,6 +16,10 @@
     <p:sldId id="264" r:id="rId15"/>
     <p:sldId id="265" r:id="rId16"/>
     <p:sldId id="266" r:id="rId17"/>
+    <p:sldId id="267" r:id="rId18"/>
+    <p:sldId id="268" r:id="rId19"/>
+    <p:sldId id="269" r:id="rId20"/>
+    <p:sldId id="270" r:id="rId21"/>
   </p:sldIdLst>
   <p:sldSz cx="9144000" cy="6858000" type="screen4x3"/>
   <p:notesSz cx="6858000" cy="9144000"/>
@@ -3135,7 +3139,7 @@
           <a:lstStyle/>
           <a:p>
             <a:r>
-              <a:t>Independent learning lab. This is an independent, free, learning-only student project. It respects every company and vendor. Trademarks belong to their owners. It is not affiliated with or endorsed by Amazon Web Services, Cisco, Genesys, or any other company. If you have a concern, the page will be removed or corrected promptly through the contact form. Nothing here is sold. There are no ads. The author is happy to volunteer for any organization.</a:t>
+              <a:t>Independent learning lab. This is an independent, free, learning-only student project. It respects every company and vendor. Trademarks belong to their owners. It is not affiliated with or endorsed by Amazon Web Services, Cisco, Genesys, Salesforce, Twilio, or any other company. If you have a concern, the page will be removed or corrected promptly through the contact form. Nothing here is sold. There are no ads. The author is happy to volunteer for any organization.</a:t>
             </a:r>
           </a:p>
         </p:txBody>
@@ -3174,7 +3178,7 @@
           <a:lstStyle/>
           <a:p>
             <a:r>
-              <a:t>Confirm</a:t>
+              <a:t>Skills routing</a:t>
             </a:r>
           </a:p>
         </p:txBody>
@@ -3198,7 +3202,7 @@
               <a:defRPr sz="2000"/>
             </a:pPr>
             <a:r>
-              <a:t>Prices, quotas, and exam names change. Confirm before relying. Nothing in this deck is an invoice.</a:t>
+              <a:t>Proficiency steps run after Transfer to queue. They do not run in an agent queue.</a:t>
             </a:r>
           </a:p>
         </p:txBody>
@@ -3237,6 +3241,258 @@
           <a:lstStyle/>
           <a:p>
             <a:r>
+              <a:t>Forecasting</a:t>
+            </a:r>
+          </a:p>
+        </p:txBody>
+      </p:sp>
+      <p:sp>
+        <p:nvSpPr>
+          <p:cNvPr id="3" name="Content Placeholder 2"/>
+          <p:cNvSpPr>
+            <a:spLocks noGrp="1"/>
+          </p:cNvSpPr>
+          <p:nvPr>
+            <p:ph idx="1"/>
+          </p:nvPr>
+        </p:nvSpPr>
+        <p:spPr/>
+        <p:txBody>
+          <a:bodyPr/>
+          <a:lstStyle/>
+          <a:p>
+            <a:pPr>
+              <a:defRPr sz="2000"/>
+            </a:pPr>
+            <a:r>
+              <a:t>Set 15 or 30 minutes once. Publish a forecast before a schedule. Adherence follows a published schedule.</a:t>
+            </a:r>
+          </a:p>
+        </p:txBody>
+      </p:sp>
+    </p:spTree>
+  </p:cSld>
+  <p:clrMapOvr>
+    <a:masterClrMapping/>
+  </p:clrMapOvr>
+</p:sld>
+</file>
+
+<file path=ppt/slides/slide12.xml><?xml version="1.0" encoding="utf-8"?>
+<p:sld xmlns:a="http://schemas.openxmlformats.org/drawingml/2006/main" xmlns:p="http://schemas.openxmlformats.org/presentationml/2006/main" xmlns:r="http://schemas.openxmlformats.org/officeDocument/2006/relationships">
+  <p:cSld>
+    <p:spTree>
+      <p:nvGrpSpPr>
+        <p:cNvPr id="1" name=""/>
+        <p:cNvGrpSpPr/>
+        <p:nvPr/>
+      </p:nvGrpSpPr>
+      <p:grpSpPr/>
+      <p:sp>
+        <p:nvSpPr>
+          <p:cNvPr id="2" name="Title 1"/>
+          <p:cNvSpPr>
+            <a:spLocks noGrp="1"/>
+          </p:cNvSpPr>
+          <p:nvPr>
+            <p:ph type="title"/>
+          </p:nvPr>
+        </p:nvSpPr>
+        <p:spPr/>
+        <p:txBody>
+          <a:bodyPr/>
+          <a:lstStyle/>
+          <a:p>
+            <a:r>
+              <a:t>Quality</a:t>
+            </a:r>
+          </a:p>
+        </p:txBody>
+      </p:sp>
+      <p:sp>
+        <p:nvSpPr>
+          <p:cNvPr id="3" name="Content Placeholder 2"/>
+          <p:cNvSpPr>
+            <a:spLocks noGrp="1"/>
+          </p:cNvSpPr>
+          <p:nvPr>
+            <p:ph idx="1"/>
+          </p:nvPr>
+        </p:nvSpPr>
+        <p:spPr/>
+        <p:txBody>
+          <a:bodyPr/>
+          <a:lstStyle/>
+          <a:p>
+            <a:pPr>
+              <a:defRPr sz="2000"/>
+            </a:pPr>
+            <a:r>
+              <a:t>Conversational analytics needs the flow block. An evaluation form is activated after its questions exist.</a:t>
+            </a:r>
+          </a:p>
+        </p:txBody>
+      </p:sp>
+    </p:spTree>
+  </p:cSld>
+  <p:clrMapOvr>
+    <a:masterClrMapping/>
+  </p:clrMapOvr>
+</p:sld>
+</file>
+
+<file path=ppt/slides/slide13.xml><?xml version="1.0" encoding="utf-8"?>
+<p:sld xmlns:a="http://schemas.openxmlformats.org/drawingml/2006/main" xmlns:p="http://schemas.openxmlformats.org/presentationml/2006/main" xmlns:r="http://schemas.openxmlformats.org/officeDocument/2006/relationships">
+  <p:cSld>
+    <p:spTree>
+      <p:nvGrpSpPr>
+        <p:cNvPr id="1" name=""/>
+        <p:cNvGrpSpPr/>
+        <p:nvPr/>
+      </p:nvGrpSpPr>
+      <p:grpSpPr/>
+      <p:sp>
+        <p:nvSpPr>
+          <p:cNvPr id="2" name="Title 1"/>
+          <p:cNvSpPr>
+            <a:spLocks noGrp="1"/>
+          </p:cNvSpPr>
+          <p:nvPr>
+            <p:ph type="title"/>
+          </p:nvPr>
+        </p:nvSpPr>
+        <p:spPr/>
+        <p:txBody>
+          <a:bodyPr/>
+          <a:lstStyle/>
+          <a:p>
+            <a:r>
+              <a:t>CRM and CPaaS</a:t>
+            </a:r>
+          </a:p>
+        </p:txBody>
+      </p:sp>
+      <p:sp>
+        <p:nvSpPr>
+          <p:cNvPr id="3" name="Content Placeholder 2"/>
+          <p:cNvSpPr>
+            <a:spLocks noGrp="1"/>
+          </p:cNvSpPr>
+          <p:nvPr>
+            <p:ph idx="1"/>
+          </p:nvPr>
+        </p:nvSpPr>
+        <p:spPr/>
+        <p:txBody>
+          <a:bodyPr/>
+          <a:lstStyle/>
+          <a:p>
+            <a:pPr>
+              <a:defRPr sz="2000"/>
+            </a:pPr>
+            <a:r>
+              <a:t>Salesforce on Connect is a CCP embed, sandbox first. Twilio Flex documents its own embed. No Connect connector page was opened.</a:t>
+            </a:r>
+          </a:p>
+        </p:txBody>
+      </p:sp>
+    </p:spTree>
+  </p:cSld>
+  <p:clrMapOvr>
+    <a:masterClrMapping/>
+  </p:clrMapOvr>
+</p:sld>
+</file>
+
+<file path=ppt/slides/slide14.xml><?xml version="1.0" encoding="utf-8"?>
+<p:sld xmlns:a="http://schemas.openxmlformats.org/drawingml/2006/main" xmlns:p="http://schemas.openxmlformats.org/presentationml/2006/main" xmlns:r="http://schemas.openxmlformats.org/officeDocument/2006/relationships">
+  <p:cSld>
+    <p:spTree>
+      <p:nvGrpSpPr>
+        <p:cNvPr id="1" name=""/>
+        <p:cNvGrpSpPr/>
+        <p:nvPr/>
+      </p:nvGrpSpPr>
+      <p:grpSpPr/>
+      <p:sp>
+        <p:nvSpPr>
+          <p:cNvPr id="2" name="Title 1"/>
+          <p:cNvSpPr>
+            <a:spLocks noGrp="1"/>
+          </p:cNvSpPr>
+          <p:nvPr>
+            <p:ph type="title"/>
+          </p:nvPr>
+        </p:nvSpPr>
+        <p:spPr/>
+        <p:txBody>
+          <a:bodyPr/>
+          <a:lstStyle/>
+          <a:p>
+            <a:r>
+              <a:t>Confirm</a:t>
+            </a:r>
+          </a:p>
+        </p:txBody>
+      </p:sp>
+      <p:sp>
+        <p:nvSpPr>
+          <p:cNvPr id="3" name="Content Placeholder 2"/>
+          <p:cNvSpPr>
+            <a:spLocks noGrp="1"/>
+          </p:cNvSpPr>
+          <p:nvPr>
+            <p:ph idx="1"/>
+          </p:nvPr>
+        </p:nvSpPr>
+        <p:spPr/>
+        <p:txBody>
+          <a:bodyPr/>
+          <a:lstStyle/>
+          <a:p>
+            <a:pPr>
+              <a:defRPr sz="2000"/>
+            </a:pPr>
+            <a:r>
+              <a:t>Prices, quotas, and exam names change. Confirm before relying. Nothing in this deck is an invoice.</a:t>
+            </a:r>
+          </a:p>
+        </p:txBody>
+      </p:sp>
+    </p:spTree>
+  </p:cSld>
+  <p:clrMapOvr>
+    <a:masterClrMapping/>
+  </p:clrMapOvr>
+</p:sld>
+</file>
+
+<file path=ppt/slides/slide15.xml><?xml version="1.0" encoding="utf-8"?>
+<p:sld xmlns:a="http://schemas.openxmlformats.org/drawingml/2006/main" xmlns:p="http://schemas.openxmlformats.org/presentationml/2006/main" xmlns:r="http://schemas.openxmlformats.org/officeDocument/2006/relationships">
+  <p:cSld>
+    <p:spTree>
+      <p:nvGrpSpPr>
+        <p:cNvPr id="1" name=""/>
+        <p:cNvGrpSpPr/>
+        <p:nvPr/>
+      </p:nvGrpSpPr>
+      <p:grpSpPr/>
+      <p:sp>
+        <p:nvSpPr>
+          <p:cNvPr id="2" name="Title 1"/>
+          <p:cNvSpPr>
+            <a:spLocks noGrp="1"/>
+          </p:cNvSpPr>
+          <p:nvPr>
+            <p:ph type="title"/>
+          </p:nvPr>
+        </p:nvSpPr>
+        <p:spPr/>
+        <p:txBody>
+          <a:bodyPr/>
+          <a:lstStyle/>
+          <a:p>
+            <a:r>
               <a:t>Sources and go deeper</a:t>
             </a:r>
           </a:p>
@@ -3258,7 +3514,7 @@
           <a:lstStyle/>
           <a:p>
             <a:r>
-              <a:t>This is an independent, free, learning-only student project. It respects every company and vendor. Trademarks belong to their owners. It is not affiliated with or endorsed by Amazon Web Services, Cisco, Genesys, or any other company. If you have a concern, the page will be removed or corrected promptly through the contact form. Nothing here is sold. There are no ads. The author is happy to volunteer for any organization.</a:t>
+              <a:t>This is an independent, free, learning-only student project. It respects every company and vendor. Trademarks belong to their owners. It is not affiliated with or endorsed by Amazon Web Services, Cisco, Genesys, Salesforce, Twilio, or any other company. If you have a concern, the page will be removed or corrected promptly through the contact form. Nothing here is sold. There are no ads. The author is happy to volunteer for any organization.</a:t>
             </a:r>
           </a:p>
           <a:p>

</xml_diff>